<commit_message>
Update to decribe "Total Value" graph option.
</commit_message>
<xml_diff>
--- a/docx/help.pptx
+++ b/docx/help.pptx
@@ -272,7 +272,7 @@
           <a:p>
             <a:fld id="{D214DC0E-3B1D-564B-9FE6-D700E32B79F0}" type="datetimeFigureOut">
               <a:rPr lang="en-US" smtClean="0"/>
-              <a:t>5/22/25</a:t>
+              <a:t>11/7/25</a:t>
             </a:fld>
             <a:endParaRPr lang="en-US"/>
           </a:p>
@@ -470,7 +470,7 @@
           <a:p>
             <a:fld id="{D214DC0E-3B1D-564B-9FE6-D700E32B79F0}" type="datetimeFigureOut">
               <a:rPr lang="en-US" smtClean="0"/>
-              <a:t>5/22/25</a:t>
+              <a:t>11/7/25</a:t>
             </a:fld>
             <a:endParaRPr lang="en-US"/>
           </a:p>
@@ -678,7 +678,7 @@
           <a:p>
             <a:fld id="{D214DC0E-3B1D-564B-9FE6-D700E32B79F0}" type="datetimeFigureOut">
               <a:rPr lang="en-US" smtClean="0"/>
-              <a:t>5/22/25</a:t>
+              <a:t>11/7/25</a:t>
             </a:fld>
             <a:endParaRPr lang="en-US"/>
           </a:p>
@@ -876,7 +876,7 @@
           <a:p>
             <a:fld id="{D214DC0E-3B1D-564B-9FE6-D700E32B79F0}" type="datetimeFigureOut">
               <a:rPr lang="en-US" smtClean="0"/>
-              <a:t>5/22/25</a:t>
+              <a:t>11/7/25</a:t>
             </a:fld>
             <a:endParaRPr lang="en-US"/>
           </a:p>
@@ -1151,7 +1151,7 @@
           <a:p>
             <a:fld id="{D214DC0E-3B1D-564B-9FE6-D700E32B79F0}" type="datetimeFigureOut">
               <a:rPr lang="en-US" smtClean="0"/>
-              <a:t>5/22/25</a:t>
+              <a:t>11/7/25</a:t>
             </a:fld>
             <a:endParaRPr lang="en-US"/>
           </a:p>
@@ -1416,7 +1416,7 @@
           <a:p>
             <a:fld id="{D214DC0E-3B1D-564B-9FE6-D700E32B79F0}" type="datetimeFigureOut">
               <a:rPr lang="en-US" smtClean="0"/>
-              <a:t>5/22/25</a:t>
+              <a:t>11/7/25</a:t>
             </a:fld>
             <a:endParaRPr lang="en-US"/>
           </a:p>
@@ -1828,7 +1828,7 @@
           <a:p>
             <a:fld id="{D214DC0E-3B1D-564B-9FE6-D700E32B79F0}" type="datetimeFigureOut">
               <a:rPr lang="en-US" smtClean="0"/>
-              <a:t>5/22/25</a:t>
+              <a:t>11/7/25</a:t>
             </a:fld>
             <a:endParaRPr lang="en-US"/>
           </a:p>
@@ -1969,7 +1969,7 @@
           <a:p>
             <a:fld id="{D214DC0E-3B1D-564B-9FE6-D700E32B79F0}" type="datetimeFigureOut">
               <a:rPr lang="en-US" smtClean="0"/>
-              <a:t>5/22/25</a:t>
+              <a:t>11/7/25</a:t>
             </a:fld>
             <a:endParaRPr lang="en-US"/>
           </a:p>
@@ -2082,7 +2082,7 @@
           <a:p>
             <a:fld id="{D214DC0E-3B1D-564B-9FE6-D700E32B79F0}" type="datetimeFigureOut">
               <a:rPr lang="en-US" smtClean="0"/>
-              <a:t>5/22/25</a:t>
+              <a:t>11/7/25</a:t>
             </a:fld>
             <a:endParaRPr lang="en-US"/>
           </a:p>
@@ -2393,7 +2393,7 @@
           <a:p>
             <a:fld id="{D214DC0E-3B1D-564B-9FE6-D700E32B79F0}" type="datetimeFigureOut">
               <a:rPr lang="en-US" smtClean="0"/>
-              <a:t>5/22/25</a:t>
+              <a:t>11/7/25</a:t>
             </a:fld>
             <a:endParaRPr lang="en-US"/>
           </a:p>
@@ -2681,7 +2681,7 @@
           <a:p>
             <a:fld id="{D214DC0E-3B1D-564B-9FE6-D700E32B79F0}" type="datetimeFigureOut">
               <a:rPr lang="en-US" smtClean="0"/>
-              <a:t>5/22/25</a:t>
+              <a:t>11/7/25</a:t>
             </a:fld>
             <a:endParaRPr lang="en-US"/>
           </a:p>
@@ -2922,7 +2922,7 @@
           <a:p>
             <a:fld id="{D214DC0E-3B1D-564B-9FE6-D700E32B79F0}" type="datetimeFigureOut">
               <a:rPr lang="en-US" smtClean="0"/>
-              <a:t>5/22/25</a:t>
+              <a:t>11/7/25</a:t>
             </a:fld>
             <a:endParaRPr lang="en-US"/>
           </a:p>
@@ -4050,10 +4050,10 @@
       </p:grpSpPr>
       <p:pic>
         <p:nvPicPr>
-          <p:cNvPr id="2" name="Picture 1">
-            <a:extLst>
-              <a:ext uri="{FF2B5EF4-FFF2-40B4-BE49-F238E27FC236}">
-                <a16:creationId xmlns:a16="http://schemas.microsoft.com/office/drawing/2014/main" id="{07B4E7C8-FE4C-4E14-876C-51B3857E5560}"/>
+          <p:cNvPr id="3" name="Picture 2">
+            <a:extLst>
+              <a:ext uri="{FF2B5EF4-FFF2-40B4-BE49-F238E27FC236}">
+                <a16:creationId xmlns:a16="http://schemas.microsoft.com/office/drawing/2014/main" id="{626FF473-F5DE-9C38-2821-37CF2F994072}"/>
               </a:ext>
             </a:extLst>
           </p:cNvPr>
@@ -4070,8 +4070,8 @@
         </p:blipFill>
         <p:spPr>
           <a:xfrm>
-            <a:off x="3792304" y="588578"/>
-            <a:ext cx="3324483" cy="4099035"/>
+            <a:off x="3987800" y="171450"/>
+            <a:ext cx="2909137" cy="4495143"/>
           </a:xfrm>
           <a:prstGeom prst="rect">
             <a:avLst/>

</xml_diff>

<commit_message>
Add Scneario type for "Taxable Income Limit"
</commit_message>
<xml_diff>
--- a/docx/help.pptx
+++ b/docx/help.pptx
@@ -272,7 +272,7 @@
           <a:p>
             <a:fld id="{D214DC0E-3B1D-564B-9FE6-D700E32B79F0}" type="datetimeFigureOut">
               <a:rPr lang="en-US" smtClean="0"/>
-              <a:t>11/7/25</a:t>
+              <a:t>12/31/25</a:t>
             </a:fld>
             <a:endParaRPr lang="en-US"/>
           </a:p>
@@ -470,7 +470,7 @@
           <a:p>
             <a:fld id="{D214DC0E-3B1D-564B-9FE6-D700E32B79F0}" type="datetimeFigureOut">
               <a:rPr lang="en-US" smtClean="0"/>
-              <a:t>11/7/25</a:t>
+              <a:t>12/31/25</a:t>
             </a:fld>
             <a:endParaRPr lang="en-US"/>
           </a:p>
@@ -678,7 +678,7 @@
           <a:p>
             <a:fld id="{D214DC0E-3B1D-564B-9FE6-D700E32B79F0}" type="datetimeFigureOut">
               <a:rPr lang="en-US" smtClean="0"/>
-              <a:t>11/7/25</a:t>
+              <a:t>12/31/25</a:t>
             </a:fld>
             <a:endParaRPr lang="en-US"/>
           </a:p>
@@ -876,7 +876,7 @@
           <a:p>
             <a:fld id="{D214DC0E-3B1D-564B-9FE6-D700E32B79F0}" type="datetimeFigureOut">
               <a:rPr lang="en-US" smtClean="0"/>
-              <a:t>11/7/25</a:t>
+              <a:t>12/31/25</a:t>
             </a:fld>
             <a:endParaRPr lang="en-US"/>
           </a:p>
@@ -1151,7 +1151,7 @@
           <a:p>
             <a:fld id="{D214DC0E-3B1D-564B-9FE6-D700E32B79F0}" type="datetimeFigureOut">
               <a:rPr lang="en-US" smtClean="0"/>
-              <a:t>11/7/25</a:t>
+              <a:t>12/31/25</a:t>
             </a:fld>
             <a:endParaRPr lang="en-US"/>
           </a:p>
@@ -1416,7 +1416,7 @@
           <a:p>
             <a:fld id="{D214DC0E-3B1D-564B-9FE6-D700E32B79F0}" type="datetimeFigureOut">
               <a:rPr lang="en-US" smtClean="0"/>
-              <a:t>11/7/25</a:t>
+              <a:t>12/31/25</a:t>
             </a:fld>
             <a:endParaRPr lang="en-US"/>
           </a:p>
@@ -1828,7 +1828,7 @@
           <a:p>
             <a:fld id="{D214DC0E-3B1D-564B-9FE6-D700E32B79F0}" type="datetimeFigureOut">
               <a:rPr lang="en-US" smtClean="0"/>
-              <a:t>11/7/25</a:t>
+              <a:t>12/31/25</a:t>
             </a:fld>
             <a:endParaRPr lang="en-US"/>
           </a:p>
@@ -1969,7 +1969,7 @@
           <a:p>
             <a:fld id="{D214DC0E-3B1D-564B-9FE6-D700E32B79F0}" type="datetimeFigureOut">
               <a:rPr lang="en-US" smtClean="0"/>
-              <a:t>11/7/25</a:t>
+              <a:t>12/31/25</a:t>
             </a:fld>
             <a:endParaRPr lang="en-US"/>
           </a:p>
@@ -2082,7 +2082,7 @@
           <a:p>
             <a:fld id="{D214DC0E-3B1D-564B-9FE6-D700E32B79F0}" type="datetimeFigureOut">
               <a:rPr lang="en-US" smtClean="0"/>
-              <a:t>11/7/25</a:t>
+              <a:t>12/31/25</a:t>
             </a:fld>
             <a:endParaRPr lang="en-US"/>
           </a:p>
@@ -2393,7 +2393,7 @@
           <a:p>
             <a:fld id="{D214DC0E-3B1D-564B-9FE6-D700E32B79F0}" type="datetimeFigureOut">
               <a:rPr lang="en-US" smtClean="0"/>
-              <a:t>11/7/25</a:t>
+              <a:t>12/31/25</a:t>
             </a:fld>
             <a:endParaRPr lang="en-US"/>
           </a:p>
@@ -2681,7 +2681,7 @@
           <a:p>
             <a:fld id="{D214DC0E-3B1D-564B-9FE6-D700E32B79F0}" type="datetimeFigureOut">
               <a:rPr lang="en-US" smtClean="0"/>
-              <a:t>11/7/25</a:t>
+              <a:t>12/31/25</a:t>
             </a:fld>
             <a:endParaRPr lang="en-US"/>
           </a:p>
@@ -2922,7 +2922,7 @@
           <a:p>
             <a:fld id="{D214DC0E-3B1D-564B-9FE6-D700E32B79F0}" type="datetimeFigureOut">
               <a:rPr lang="en-US" smtClean="0"/>
-              <a:t>11/7/25</a:t>
+              <a:t>12/31/25</a:t>
             </a:fld>
             <a:endParaRPr lang="en-US"/>
           </a:p>
@@ -5894,7 +5894,7 @@
             </a:pPr>
             <a:r>
               <a:rPr lang="en-US" sz="1200" dirty="0"/>
-              <a:t>Amount Constraint (“Fixed Amount” or “MAGI Limited”)</a:t>
+              <a:t>Amount Constraint (“Fixed Amount” or “MAGI Limited” or “Taxable Income Limit”)</a:t>
             </a:r>
           </a:p>
           <a:p>

</xml_diff>